<commit_message>
Remove teacher-facing labels from slides; move to speaker notes
- Drop 'Instructor-Created Example' / 'EXAMPLE (Instructor-Created)' labels
  from example callouts (now just 'EXAMPLE:')
- Remove the instructor-created labeling note from the intro slide and the
  case-study panel, and the 'formatted for illustration' subtitle on Slide 25
- Preserve this provenance information in each affected slide's speaker notes
- Reflow Slide 25 entries and the case-study panel to use the freed space
- Re-verified: 16:9, all notes intact, no overflow, no student-visible labels
</commit_message>
<xml_diff>
--- a/Lecture2-Research-Ethics.pptx
+++ b/Lecture2-Research-Ethics.pptx
@@ -610,6 +610,12 @@
               <a:t>Visual: none necessary.</a:t>
             </a:r>
           </a:p>
+          <a:p/>
+          <a:p>
+            <a:r>
+              <a:t>[Provenance] The EXAMPLE on this slide is an instructor-created scenario (not drawn from the textbook). This label is kept in the notes only, not on the student slide.</a:t>
+            </a:r>
+          </a:p>
         </p:txBody>
       </p:sp>
       <p:sp>
@@ -686,6 +692,12 @@
               <a:t>Visual: none necessary.</a:t>
             </a:r>
           </a:p>
+          <a:p/>
+          <a:p>
+            <a:r>
+              <a:t>[Provenance] The EXAMPLE on this slide is an instructor-created scenario (not drawn from the textbook). This label is kept in the notes only, not on the student slide.</a:t>
+            </a:r>
+          </a:p>
         </p:txBody>
       </p:sp>
       <p:sp>
@@ -762,6 +774,12 @@
               <a:t>Visual: none necessary.</a:t>
             </a:r>
           </a:p>
+          <a:p/>
+          <a:p>
+            <a:r>
+              <a:t>[Provenance] The EXAMPLE on this slide is an instructor-created scenario (not drawn from the textbook). This label is kept in the notes only, not on the student slide.</a:t>
+            </a:r>
+          </a:p>
         </p:txBody>
       </p:sp>
       <p:sp>
@@ -914,6 +932,12 @@
               <a:t>Visual: the same five-stage flowchart from Slide 2, with the 'Planning' box highlighted. Reusing this exact graphic across Slides 12-15 lets students track lesson progress at a glance.</a:t>
             </a:r>
           </a:p>
+          <a:p/>
+          <a:p>
+            <a:r>
+              <a:t>[Provenance] The EXAMPLE on this slide is an instructor-created scenario (not drawn from the textbook). This label is kept in the notes only, not on the student slide.</a:t>
+            </a:r>
+          </a:p>
         </p:txBody>
       </p:sp>
       <p:sp>
@@ -990,6 +1014,12 @@
               <a:t>Visual: same flowchart graphic, now with 'Collecting Data' highlighted.</a:t>
             </a:r>
           </a:p>
+          <a:p/>
+          <a:p>
+            <a:r>
+              <a:t>[Provenance] The EXAMPLE on this slide is an instructor-created scenario (not drawn from the textbook). This label is kept in the notes only, not on the student slide.</a:t>
+            </a:r>
+          </a:p>
         </p:txBody>
       </p:sp>
       <p:sp>
@@ -1066,6 +1096,12 @@
               <a:t>Visual: same flowchart graphic, now with 'Analyzing Data' highlighted.</a:t>
             </a:r>
           </a:p>
+          <a:p/>
+          <a:p>
+            <a:r>
+              <a:t>[Provenance] The EXAMPLE on this slide is an instructor-created scenario (not drawn from the textbook). This label is kept in the notes only, not on the student slide.</a:t>
+            </a:r>
+          </a:p>
         </p:txBody>
       </p:sp>
       <p:sp>
@@ -1294,6 +1330,12 @@
               <a:t>Visual: none necessary.</a:t>
             </a:r>
           </a:p>
+          <a:p/>
+          <a:p>
+            <a:r>
+              <a:t>[Provenance] The EXAMPLE on this slide is an instructor-created scenario (not drawn from the textbook). This label is kept in the notes only, not on the student slide.</a:t>
+            </a:r>
+          </a:p>
         </p:txBody>
       </p:sp>
       <p:sp>
@@ -1972,6 +2014,12 @@
               <a:t>Visual: none necessary — the three fully formatted entries are themselves the instructional content.</a:t>
             </a:r>
           </a:p>
+          <a:p/>
+          <a:p>
+            <a:r>
+              <a:t>[Provenance] These three sample reference entries are instructor-created and formatted for illustration only.</a:t>
+            </a:r>
+          </a:p>
         </p:txBody>
       </p:sp>
       <p:sp>
@@ -2724,6 +2772,12 @@
           <a:p>
             <a:r>
               <a:t>Visual: none necessary — the example is brief enough to sit directly on the concept slide.</a:t>
+            </a:r>
+          </a:p>
+          <a:p/>
+          <a:p>
+            <a:r>
+              <a:t>[Provenance] The EXAMPLE on this slide is an instructor-created scenario (not drawn from the textbook). This label is kept in the notes only, not on the student slide.</a:t>
             </a:r>
           </a:p>
         </p:txBody>
@@ -7142,7 +7196,7 @@
                 </a:solidFill>
                 <a:latin typeface="Segoe UI Semibold"/>
               </a:rPr>
-              <a:t>EXAMPLE (Instructor-Created):  </a:t>
+              <a:t>EXAMPLE:  </a:t>
             </a:r>
           </a:p>
           <a:p>
@@ -7847,7 +7901,7 @@
                 </a:solidFill>
                 <a:latin typeface="Segoe UI Semibold"/>
               </a:rPr>
-              <a:t>EXAMPLE (Instructor-Created):  </a:t>
+              <a:t>EXAMPLE:  </a:t>
             </a:r>
           </a:p>
           <a:p>
@@ -8565,7 +8619,7 @@
                 </a:solidFill>
                 <a:latin typeface="Segoe UI Semibold"/>
               </a:rPr>
-              <a:t>EXAMPLE (Instructor-Created):  </a:t>
+              <a:t>EXAMPLE:  </a:t>
             </a:r>
           </a:p>
           <a:p>
@@ -11393,7 +11447,7 @@
                 </a:solidFill>
                 <a:latin typeface="Segoe UI Semibold"/>
               </a:rPr>
-              <a:t>EXAMPLE (Instructor-Created):  </a:t>
+              <a:t>EXAMPLE:  </a:t>
             </a:r>
           </a:p>
           <a:p>
@@ -12566,7 +12620,7 @@
                 </a:solidFill>
                 <a:latin typeface="Segoe UI Semibold"/>
               </a:rPr>
-              <a:t>EXAMPLE (Instructor-Created):  </a:t>
+              <a:t>EXAMPLE:  </a:t>
             </a:r>
           </a:p>
           <a:p>
@@ -13690,7 +13744,7 @@
                 </a:solidFill>
                 <a:latin typeface="Segoe UI Semibold"/>
               </a:rPr>
-              <a:t>EXAMPLE (Instructor-Created):  </a:t>
+              <a:t>EXAMPLE:  </a:t>
             </a:r>
           </a:p>
           <a:p>
@@ -17195,7 +17249,7 @@
                 </a:solidFill>
                 <a:latin typeface="Segoe UI Semibold"/>
               </a:rPr>
-              <a:t>EXAMPLE (Instructor-Created):  </a:t>
+              <a:t>EXAMPLE:  </a:t>
             </a:r>
           </a:p>
           <a:p>
@@ -17738,25 +17792,7 @@
                 </a:solidFill>
                 <a:latin typeface="Segoe UI"/>
               </a:rPr>
-              <a:t> — the “Ethical Issues” section and Table 4.1. Examples not from the textbook are labeled </a:t>
-            </a:r>
-            <a:r>
-              <a:rPr sz="1859" b="1" i="0">
-                <a:solidFill>
-                  <a:srgbClr val="212A33"/>
-                </a:solidFill>
-                <a:latin typeface="Segoe UI"/>
-              </a:rPr>
-              <a:t>Instructor-Created Example</a:t>
-            </a:r>
-            <a:r>
-              <a:rPr sz="1859" b="0" i="0">
-                <a:solidFill>
-                  <a:srgbClr val="212A33"/>
-                </a:solidFill>
-                <a:latin typeface="Segoe UI"/>
-              </a:rPr>
-              <a:t>.</a:t>
+              <a:t> — the “Ethical Issues” section and Table 4.1.</a:t>
             </a:r>
           </a:p>
         </p:txBody>
@@ -17912,8 +17948,8 @@
         </p:nvSpPr>
         <p:spPr>
           <a:xfrm>
-            <a:off x="6675120" y="2606040"/>
-            <a:ext cx="4526280" cy="3246120"/>
+            <a:off x="6675120" y="2651760"/>
+            <a:ext cx="4526280" cy="3200400"/>
           </a:xfrm>
           <a:prstGeom prst="rect">
             <a:avLst/>
@@ -17921,7 +17957,7 @@
           <a:noFill/>
         </p:spPr>
         <p:txBody>
-          <a:bodyPr wrap="square" anchor="t" lIns="0" rIns="0" tIns="0" bIns="0">
+          <a:bodyPr wrap="square" anchor="ctr" lIns="0" rIns="0" tIns="0" bIns="0">
             <a:spAutoFit/>
           </a:bodyPr>
           <a:lstStyle/>
@@ -17934,39 +17970,17 @@
                 <a:spcPts val="0"/>
               </a:spcBef>
               <a:spcAft>
-                <a:spcPts val="300"/>
-              </a:spcAft>
-            </a:pPr>
-            <a:r>
-              <a:rPr sz="2039" b="1" i="0">
-                <a:solidFill>
-                  <a:srgbClr val="0F4C5C"/>
-                </a:solidFill>
-                <a:latin typeface="Segoe UI Semibold"/>
-              </a:rPr>
-              <a:t>The Barangay Water Filter Project</a:t>
-            </a:r>
-          </a:p>
-          <a:p>
-            <a:pPr algn="l">
-              <a:lnSpc>
-                <a:spcPct val="106000"/>
-              </a:lnSpc>
-              <a:spcBef>
-                <a:spcPts val="0"/>
-              </a:spcBef>
-              <a:spcAft>
                 <a:spcPts val="800"/>
               </a:spcAft>
             </a:pPr>
             <a:r>
-              <a:rPr sz="1439" b="0" i="1">
-                <a:solidFill>
-                  <a:srgbClr val="5B6B73"/>
-                </a:solidFill>
-                <a:latin typeface="Segoe UI"/>
-              </a:rPr>
-              <a:t>Instructor-Created Example</a:t>
+              <a:rPr sz="2039" b="1" i="0">
+                <a:solidFill>
+                  <a:srgbClr val="0F4C5C"/>
+                </a:solidFill>
+                <a:latin typeface="Segoe UI Semibold"/>
+              </a:rPr>
+              <a:t>The Barangay Water Filter Project</a:t>
             </a:r>
           </a:p>
           <a:p>
@@ -25818,58 +25832,13 @@
       </p:sp>
       <p:sp>
         <p:nvSpPr>
-          <p:cNvPr id="10" name="TextBox 9"/>
-          <p:cNvSpPr txBox="1"/>
-          <p:nvPr/>
-        </p:nvSpPr>
-        <p:spPr>
-          <a:xfrm>
-            <a:off x="640080" y="1737360"/>
-            <a:ext cx="10881360" cy="411480"/>
-          </a:xfrm>
-          <a:prstGeom prst="rect">
-            <a:avLst/>
-          </a:prstGeom>
-          <a:noFill/>
-        </p:spPr>
-        <p:txBody>
-          <a:bodyPr wrap="square" anchor="t" lIns="0" rIns="0" tIns="0" bIns="0">
-            <a:spAutoFit/>
-          </a:bodyPr>
-          <a:lstStyle/>
-          <a:p>
-            <a:pPr algn="l">
-              <a:lnSpc>
-                <a:spcPct val="106000"/>
-              </a:lnSpc>
-              <a:spcBef>
-                <a:spcPts val="0"/>
-              </a:spcBef>
-              <a:spcAft>
-                <a:spcPts val="0"/>
-              </a:spcAft>
-            </a:pPr>
-            <a:r>
-              <a:rPr sz="1620" b="0" i="1">
-                <a:solidFill>
-                  <a:srgbClr val="5B6B73"/>
-                </a:solidFill>
-                <a:latin typeface="Segoe UI"/>
-              </a:rPr>
-              <a:t>Instructor-Created Examples, formatted for illustration</a:t>
-            </a:r>
-          </a:p>
-        </p:txBody>
-      </p:sp>
-      <p:sp>
-        <p:nvSpPr>
-          <p:cNvPr id="11" name="Rounded Rectangle 10"/>
+          <p:cNvPr id="10" name="Rounded Rectangle 9"/>
           <p:cNvSpPr/>
           <p:nvPr/>
         </p:nvSpPr>
         <p:spPr>
           <a:xfrm>
-            <a:off x="640080" y="2286000"/>
+            <a:off x="640080" y="2103120"/>
             <a:ext cx="10881360" cy="1234440"/>
           </a:xfrm>
           <a:prstGeom prst="roundRect">
@@ -25917,13 +25886,13 @@
       </p:sp>
       <p:sp>
         <p:nvSpPr>
-          <p:cNvPr id="12" name="Round Same Side Corner Rectangle 11"/>
+          <p:cNvPr id="11" name="Round Same Side Corner Rectangle 10"/>
           <p:cNvSpPr/>
           <p:nvPr/>
         </p:nvSpPr>
         <p:spPr>
           <a:xfrm>
-            <a:off x="640080" y="2286000"/>
+            <a:off x="640080" y="2103120"/>
             <a:ext cx="2103120" cy="1234440"/>
           </a:xfrm>
           <a:prstGeom prst="round2SameRect">
@@ -25961,13 +25930,13 @@
       </p:sp>
       <p:sp>
         <p:nvSpPr>
-          <p:cNvPr id="13" name="TextBox 12"/>
+          <p:cNvPr id="12" name="TextBox 11"/>
           <p:cNvSpPr txBox="1"/>
           <p:nvPr/>
         </p:nvSpPr>
         <p:spPr>
           <a:xfrm>
-            <a:off x="731520" y="2286000"/>
+            <a:off x="731520" y="2103120"/>
             <a:ext cx="1920240" cy="1234440"/>
           </a:xfrm>
           <a:prstGeom prst="rect">
@@ -26006,13 +25975,13 @@
       </p:sp>
       <p:sp>
         <p:nvSpPr>
-          <p:cNvPr id="14" name="TextBox 13"/>
+          <p:cNvPr id="13" name="TextBox 12"/>
           <p:cNvSpPr txBox="1"/>
           <p:nvPr/>
         </p:nvSpPr>
         <p:spPr>
           <a:xfrm>
-            <a:off x="2926080" y="2423160"/>
+            <a:off x="2926080" y="2240279"/>
             <a:ext cx="8366760" cy="960120"/>
           </a:xfrm>
           <a:prstGeom prst="rect">
@@ -26069,13 +26038,13 @@
       </p:sp>
       <p:sp>
         <p:nvSpPr>
-          <p:cNvPr id="15" name="Rounded Rectangle 14"/>
+          <p:cNvPr id="14" name="Rounded Rectangle 13"/>
           <p:cNvSpPr/>
           <p:nvPr/>
         </p:nvSpPr>
         <p:spPr>
           <a:xfrm>
-            <a:off x="640080" y="3703320"/>
+            <a:off x="640080" y="3538728"/>
             <a:ext cx="10881360" cy="1234440"/>
           </a:xfrm>
           <a:prstGeom prst="roundRect">
@@ -26123,13 +26092,13 @@
       </p:sp>
       <p:sp>
         <p:nvSpPr>
-          <p:cNvPr id="16" name="Round Same Side Corner Rectangle 15"/>
+          <p:cNvPr id="15" name="Round Same Side Corner Rectangle 14"/>
           <p:cNvSpPr/>
           <p:nvPr/>
         </p:nvSpPr>
         <p:spPr>
           <a:xfrm>
-            <a:off x="640080" y="3703320"/>
+            <a:off x="640080" y="3538728"/>
             <a:ext cx="2103120" cy="1234440"/>
           </a:xfrm>
           <a:prstGeom prst="round2SameRect">
@@ -26167,13 +26136,13 @@
       </p:sp>
       <p:sp>
         <p:nvSpPr>
-          <p:cNvPr id="17" name="TextBox 16"/>
+          <p:cNvPr id="16" name="TextBox 15"/>
           <p:cNvSpPr txBox="1"/>
           <p:nvPr/>
         </p:nvSpPr>
         <p:spPr>
           <a:xfrm>
-            <a:off x="731520" y="3703320"/>
+            <a:off x="731520" y="3538728"/>
             <a:ext cx="1920240" cy="1234440"/>
           </a:xfrm>
           <a:prstGeom prst="rect">
@@ -26212,13 +26181,13 @@
       </p:sp>
       <p:sp>
         <p:nvSpPr>
-          <p:cNvPr id="18" name="TextBox 17"/>
+          <p:cNvPr id="17" name="TextBox 16"/>
           <p:cNvSpPr txBox="1"/>
           <p:nvPr/>
         </p:nvSpPr>
         <p:spPr>
           <a:xfrm>
-            <a:off x="2926080" y="3840480"/>
+            <a:off x="2926080" y="3675888"/>
             <a:ext cx="8366760" cy="960120"/>
           </a:xfrm>
           <a:prstGeom prst="rect">
@@ -26275,13 +26244,13 @@
       </p:sp>
       <p:sp>
         <p:nvSpPr>
-          <p:cNvPr id="19" name="Rounded Rectangle 18"/>
+          <p:cNvPr id="18" name="Rounded Rectangle 17"/>
           <p:cNvSpPr/>
           <p:nvPr/>
         </p:nvSpPr>
         <p:spPr>
           <a:xfrm>
-            <a:off x="640080" y="5120640"/>
+            <a:off x="640080" y="4974336"/>
             <a:ext cx="10881360" cy="1234440"/>
           </a:xfrm>
           <a:prstGeom prst="roundRect">
@@ -26329,13 +26298,13 @@
       </p:sp>
       <p:sp>
         <p:nvSpPr>
-          <p:cNvPr id="20" name="Round Same Side Corner Rectangle 19"/>
+          <p:cNvPr id="19" name="Round Same Side Corner Rectangle 18"/>
           <p:cNvSpPr/>
           <p:nvPr/>
         </p:nvSpPr>
         <p:spPr>
           <a:xfrm>
-            <a:off x="640080" y="5120640"/>
+            <a:off x="640080" y="4974336"/>
             <a:ext cx="2103120" cy="1234440"/>
           </a:xfrm>
           <a:prstGeom prst="round2SameRect">
@@ -26373,13 +26342,13 @@
       </p:sp>
       <p:sp>
         <p:nvSpPr>
-          <p:cNvPr id="21" name="TextBox 20"/>
+          <p:cNvPr id="20" name="TextBox 19"/>
           <p:cNvSpPr txBox="1"/>
           <p:nvPr/>
         </p:nvSpPr>
         <p:spPr>
           <a:xfrm>
-            <a:off x="731520" y="5120640"/>
+            <a:off x="731520" y="4974336"/>
             <a:ext cx="1920240" cy="1234440"/>
           </a:xfrm>
           <a:prstGeom prst="rect">
@@ -26418,13 +26387,13 @@
       </p:sp>
       <p:sp>
         <p:nvSpPr>
-          <p:cNvPr id="22" name="TextBox 21"/>
+          <p:cNvPr id="21" name="TextBox 20"/>
           <p:cNvSpPr txBox="1"/>
           <p:nvPr/>
         </p:nvSpPr>
         <p:spPr>
           <a:xfrm>
-            <a:off x="2926080" y="5257800"/>
+            <a:off x="2926080" y="5111496"/>
             <a:ext cx="8366760" cy="960120"/>
           </a:xfrm>
           <a:prstGeom prst="rect">
@@ -36621,7 +36590,7 @@
                 </a:solidFill>
                 <a:latin typeface="Segoe UI Semibold"/>
               </a:rPr>
-              <a:t>EXAMPLE (Instructor-Created):  </a:t>
+              <a:t>EXAMPLE:  </a:t>
             </a:r>
           </a:p>
           <a:p>

</xml_diff>